<commit_message>
chore: daily content 2026-08-29
</commit_message>
<xml_diff>
--- a/data/2026-08-29/slides.pptx
+++ b/data/2026-08-29/slides.pptx
@@ -11,7 +11,6 @@
     <p:sldId id="259" r:id="rId11"/>
     <p:sldId id="260" r:id="rId12"/>
     <p:sldId id="261" r:id="rId13"/>
-    <p:sldId id="262" r:id="rId14"/>
   </p:sldIdLst>
   <p:sldSz cx="5559552" cy="9875520" type="screen4x3"/>
   <p:notesSz cx="6858000" cy="9144000"/>
@@ -593,7 +592,7 @@
           </a:p>
           <a:p>
             <a:r>
-              <a:t>대본: 《Microbiology spectrum》 - Prospective multicenter evaluation of an easy-to-use DNA microarray for the detection of dermatophytes in clinical samples compared with conventional mycological methods</a:t>
+              <a:t>대본: 《Aging cell》 - Shelterin TPP1 Promotes Hair Regeneration Through Activating Bulge Hair Follicle Stem Cells</a:t>
             </a:r>
           </a:p>
           <a:p>
@@ -673,7 +672,7 @@
           </a:p>
           <a:p>
             <a:r>
-              <a:t>대본: Compared with culture, the DP assay showed that the sensitivity to culture was 96.4% [94.3-98.5], while the specificity was 61.2% [54.0-68.4], reflecting additional detections rather than false positives.</a:t>
+              <a:t>대본: Wang L(1), Zhao B(1)(2), Yang J(1)(2), Liang Y(1), Yao Y(1)(2), Xiao X(1)(2), Yang L(1)(2), Xia J(1)(2), Li H(1)(2), Gao L(1)(2), Zhang J(1)(2), Su T(1)(2), Xu H(1)(2), Zhang J(1)(2), Wang H(1), Liu J(1), Hong X(1), Liu JP(1)(3)(4).</a:t>
             </a:r>
           </a:p>
           <a:p>
@@ -748,17 +747,17 @@
           <a:lstStyle/>
           <a:p>
             <a:r>
-              <a:t>[key_finding_2] 약 12초</a:t>
-            </a:r>
-          </a:p>
-          <a:p>
-            <a:r>
-              <a:t>대본: The DP assay detected dermatophytes in 367/487 samples (75.4%), outperforming DE (67.4%) and culture (63.4%).</a:t>
-            </a:r>
-          </a:p>
-          <a:p>
-            <a:r>
-              <a:t>연출 노트: 핵심 포인트 2 (없으면 이 씬 스킵)</a:t>
+              <a:t>[my_take] 약 12초</a:t>
+            </a:r>
+          </a:p>
+          <a:p>
+            <a:r>
+              <a:t>대본: 본인 코멘트를 자유롭게 추가하세요.</a:t>
+            </a:r>
+          </a:p>
+          <a:p>
+            <a:r>
+              <a:t>연출 노트: 본인 사진 + 한마디 코멘트. assets/my-photo/latest.jpg 로 직접 교체.</a:t>
             </a:r>
           </a:p>
         </p:txBody>
@@ -784,86 +783,6 @@
 </file>
 
 <file path=ppt/notesSlides/notesSlide5.xml><?xml version="1.0" encoding="utf-8"?>
-<p:notes xmlns:a="http://schemas.openxmlformats.org/drawingml/2006/main" xmlns:p="http://schemas.openxmlformats.org/presentationml/2006/main" xmlns:r="http://schemas.openxmlformats.org/officeDocument/2006/relationships">
-  <p:cSld>
-    <p:spTree>
-      <p:nvGrpSpPr>
-        <p:cNvPr id="1" name=""/>
-        <p:cNvGrpSpPr/>
-        <p:nvPr/>
-      </p:nvGrpSpPr>
-      <p:grpSpPr>
-        <a:xfrm>
-          <a:off x="0" y="0"/>
-          <a:ext cx="0" cy="0"/>
-          <a:chOff x="0" y="0"/>
-          <a:chExt cx="0" cy="0"/>
-        </a:xfrm>
-      </p:grpSpPr>
-      <p:sp>
-        <p:nvSpPr>
-          <p:cNvPr id="2" name="Slide Image Placeholder 1"/>
-          <p:cNvSpPr>
-            <a:spLocks noGrp="1"/>
-          </p:cNvSpPr>
-          <p:nvPr>
-            <p:ph type="sldImg" idx="2"/>
-          </p:nvPr>
-        </p:nvSpPr>
-        <p:spPr/>
-      </p:sp>
-      <p:sp>
-        <p:nvSpPr>
-          <p:cNvPr id="3" name="Notes Placeholder 2"/>
-          <p:cNvSpPr>
-            <a:spLocks noGrp="1"/>
-          </p:cNvSpPr>
-          <p:nvPr>
-            <p:ph type="body" idx="3" sz="quarter"/>
-          </p:nvPr>
-        </p:nvSpPr>
-        <p:spPr/>
-        <p:txBody>
-          <a:bodyPr/>
-          <a:lstStyle/>
-          <a:p>
-            <a:r>
-              <a:t>[my_take] 약 12초</a:t>
-            </a:r>
-          </a:p>
-          <a:p>
-            <a:r>
-              <a:t>대본: 본인 코멘트를 자유롭게 추가하세요.</a:t>
-            </a:r>
-          </a:p>
-          <a:p>
-            <a:r>
-              <a:t>연출 노트: 본인 사진 + 한마디 코멘트. assets/my-photo/latest.jpg 로 직접 교체.</a:t>
-            </a:r>
-          </a:p>
-        </p:txBody>
-      </p:sp>
-      <p:sp>
-        <p:nvSpPr>
-          <p:cNvPr id="4" name="Slide Number Placeholder 3"/>
-          <p:cNvSpPr>
-            <a:spLocks noGrp="1"/>
-          </p:cNvSpPr>
-          <p:nvPr>
-            <p:ph type="sldNum" idx="5" sz="quarter"/>
-          </p:nvPr>
-        </p:nvSpPr>
-        <p:spPr/>
-      </p:sp>
-    </p:spTree>
-  </p:cSld>
-  <p:clrMapOvr>
-    <a:masterClrMapping/>
-  </p:clrMapOvr>
-</p:notes>
-</file>
-
-<file path=ppt/notesSlides/notesSlide6.xml><?xml version="1.0" encoding="utf-8"?>
 <p:notes xmlns:a="http://schemas.openxmlformats.org/drawingml/2006/main" xmlns:p="http://schemas.openxmlformats.org/presentationml/2006/main" xmlns:r="http://schemas.openxmlformats.org/officeDocument/2006/relationships">
   <p:cSld>
     <p:spTree>
@@ -4052,7 +3971,7 @@
       <p:grpSpPr/>
       <p:pic>
         <p:nvPicPr>
-          <p:cNvPr id="2" name="Picture 1" descr="frame_04_key_finding_2.png"/>
+          <p:cNvPr id="2" name="Picture 1" descr="frame_05_my_take.png"/>
           <p:cNvPicPr>
             <a:picLocks noChangeAspect="1"/>
           </p:cNvPicPr>
@@ -4094,7 +4013,7 @@
       <p:grpSpPr/>
       <p:pic>
         <p:nvPicPr>
-          <p:cNvPr id="2" name="Picture 1" descr="frame_05_my_take.png"/>
+          <p:cNvPr id="2" name="Picture 1" descr="frame_06_cta.png"/>
           <p:cNvPicPr>
             <a:picLocks noChangeAspect="1"/>
           </p:cNvPicPr>
@@ -4134,48 +4053,6 @@
         <p:nvPr/>
       </p:nvGrpSpPr>
       <p:grpSpPr/>
-      <p:pic>
-        <p:nvPicPr>
-          <p:cNvPr id="2" name="Picture 1" descr="frame_06_cta.png"/>
-          <p:cNvPicPr>
-            <a:picLocks noChangeAspect="1"/>
-          </p:cNvPicPr>
-          <p:nvPr/>
-        </p:nvPicPr>
-        <p:blipFill>
-          <a:blip r:embed="rId2"/>
-          <a:stretch>
-            <a:fillRect/>
-          </a:stretch>
-        </p:blipFill>
-        <p:spPr>
-          <a:xfrm>
-            <a:off x="0" y="0"/>
-            <a:ext cx="5559552" cy="9875520"/>
-          </a:xfrm>
-          <a:prstGeom prst="rect">
-            <a:avLst/>
-          </a:prstGeom>
-        </p:spPr>
-      </p:pic>
-    </p:spTree>
-  </p:cSld>
-  <p:clrMapOvr>
-    <a:masterClrMapping/>
-  </p:clrMapOvr>
-</p:sld>
-</file>
-
-<file path=ppt/slides/slide7.xml><?xml version="1.0" encoding="utf-8"?>
-<p:sld xmlns:a="http://schemas.openxmlformats.org/drawingml/2006/main" xmlns:p="http://schemas.openxmlformats.org/presentationml/2006/main" xmlns:r="http://schemas.openxmlformats.org/officeDocument/2006/relationships">
-  <p:cSld>
-    <p:spTree>
-      <p:nvGrpSpPr>
-        <p:cNvPr id="1" name=""/>
-        <p:cNvGrpSpPr/>
-        <p:nvPr/>
-      </p:nvGrpSpPr>
-      <p:grpSpPr/>
       <p:sp>
         <p:nvSpPr>
           <p:cNvPr id="2" name="TextBox 1"/>
@@ -4204,12 +4081,12 @@
           </a:p>
           <a:p>
             <a:r>
-              <a:t>Prospective multicenter evaluation of an easy-to-use DNA microarray for the detection of dermatophytes in clinical samples compared with conventional mycological methods</a:t>
-            </a:r>
-          </a:p>
-          <a:p>
-            <a:r>
-              <a:t>https://pubmed.ncbi.nlm.nih.gov/42663453/</a:t>
+              <a:t>Shelterin TPP1 Promotes Hair Regeneration Through Activating Bulge Hair Follicle Stem Cells</a:t>
+            </a:r>
+          </a:p>
+          <a:p>
+            <a:r>
+              <a:t>https://pubmed.ncbi.nlm.nih.gov/42663085/</a:t>
             </a:r>
           </a:p>
         </p:txBody>

</xml_diff>